<commit_message>
docs(deck): professional-voice pass on the modernizing decks
Remove em dashes and internal chapter/section cross-references from
deck.js prose and speaker notes across modernizing-101,
modernizing-201, and modernizing-201-fastapi, then rebuild each pptx.
</commit_message>
<xml_diff>
--- a/presentation/modernizing-101/Modernizing_101-r1.1.pptx
+++ b/presentation/modernizing-101/Modernizing_101-r1.1.pptx
@@ -2975,9 +2975,9 @@
                 <a:solidFill>
                   <a:srgbClr val="EE0000"/>
                 </a:solidFill>
-                <a:latin typeface="Overpass" pitchFamily="34" charset="0"/>
-                <a:ea typeface="Overpass" pitchFamily="34" charset="-122"/>
-                <a:cs typeface="Overpass" pitchFamily="34" charset="-120"/>
+                <a:latin typeface="Red Hat Display" pitchFamily="34" charset="0"/>
+                <a:ea typeface="Red Hat Display" pitchFamily="34" charset="-122"/>
+                <a:cs typeface="Red Hat Display" pitchFamily="34" charset="-120"/>
               </a:rPr>
               <a:t>MODERNIZING ENTERPRISE APPLICATIONS (PYTHON) · 101</a:t>
             </a:r>
@@ -3014,9 +3014,9 @@
                 <a:solidFill>
                   <a:srgbClr val="151515"/>
                 </a:solidFill>
-                <a:latin typeface="Overpass" pitchFamily="34" charset="0"/>
-                <a:ea typeface="Overpass" pitchFamily="34" charset="-122"/>
-                <a:cs typeface="Overpass" pitchFamily="34" charset="-120"/>
+                <a:latin typeface="Red Hat Display" pitchFamily="34" charset="0"/>
+                <a:ea typeface="Red Hat Display" pitchFamily="34" charset="-122"/>
+                <a:cs typeface="Red Hat Display" pitchFamily="34" charset="-120"/>
               </a:rPr>
               <a:t>Django to FastAPI,</a:t>
             </a:r>
@@ -3031,9 +3031,9 @@
                 <a:solidFill>
                   <a:srgbClr val="151515"/>
                 </a:solidFill>
-                <a:latin typeface="Overpass" pitchFamily="34" charset="0"/>
-                <a:ea typeface="Overpass" pitchFamily="34" charset="-122"/>
-                <a:cs typeface="Overpass" pitchFamily="34" charset="-120"/>
+                <a:latin typeface="Red Hat Display" pitchFamily="34" charset="0"/>
+                <a:ea typeface="Red Hat Display" pitchFamily="34" charset="-122"/>
+                <a:cs typeface="Red Hat Display" pitchFamily="34" charset="-120"/>
               </a:rPr>
               <a:t>one seam at a time</a:t>
             </a:r>
@@ -3260,9 +3260,9 @@
                 <a:solidFill>
                   <a:srgbClr val="EE0000"/>
                 </a:solidFill>
-                <a:latin typeface="Overpass" pitchFamily="34" charset="0"/>
-                <a:ea typeface="Overpass" pitchFamily="34" charset="-122"/>
-                <a:cs typeface="Overpass" pitchFamily="34" charset="-120"/>
+                <a:latin typeface="Red Hat Display" pitchFamily="34" charset="0"/>
+                <a:ea typeface="Red Hat Display" pitchFamily="34" charset="-122"/>
+                <a:cs typeface="Red Hat Display" pitchFamily="34" charset="-120"/>
               </a:rPr>
               <a:t>DATA ACROSS THE SEAM</a:t>
             </a:r>
@@ -3299,9 +3299,9 @@
                 <a:solidFill>
                   <a:srgbClr val="151515"/>
                 </a:solidFill>
-                <a:latin typeface="Overpass" pitchFamily="34" charset="0"/>
-                <a:ea typeface="Overpass" pitchFamily="34" charset="-122"/>
-                <a:cs typeface="Overpass" pitchFamily="34" charset="-120"/>
+                <a:latin typeface="Red Hat Display" pitchFamily="34" charset="0"/>
+                <a:ea typeface="Red Hat Display" pitchFamily="34" charset="-122"/>
+                <a:cs typeface="Red Hat Display" pitchFamily="34" charset="-120"/>
               </a:rPr>
               <a:t>Lead with owned data, not the shared schema</a:t>
             </a:r>
@@ -3488,9 +3488,9 @@
                 <a:solidFill>
                   <a:srgbClr val="EE0000"/>
                 </a:solidFill>
-                <a:latin typeface="Overpass" pitchFamily="34" charset="0"/>
-                <a:ea typeface="Overpass" pitchFamily="34" charset="-122"/>
-                <a:cs typeface="Overpass" pitchFamily="34" charset="-120"/>
+                <a:latin typeface="Red Hat Display" pitchFamily="34" charset="0"/>
+                <a:ea typeface="Red Hat Display" pitchFamily="34" charset="-122"/>
+                <a:cs typeface="Red Hat Display" pitchFamily="34" charset="-120"/>
               </a:rPr>
               <a:t>COORDINATING</a:t>
             </a:r>
@@ -3527,9 +3527,9 @@
                 <a:solidFill>
                   <a:srgbClr val="151515"/>
                 </a:solidFill>
-                <a:latin typeface="Overpass" pitchFamily="34" charset="0"/>
-                <a:ea typeface="Overpass" pitchFamily="34" charset="-122"/>
-                <a:cs typeface="Overpass" pitchFamily="34" charset="-120"/>
+                <a:latin typeface="Red Hat Display" pitchFamily="34" charset="0"/>
+                <a:ea typeface="Red Hat Display" pitchFamily="34" charset="-122"/>
+                <a:cs typeface="Red Hat Display" pitchFamily="34" charset="-120"/>
               </a:rPr>
               <a:t>Two ways to run a workflow across services</a:t>
             </a:r>
@@ -3716,9 +3716,9 @@
                 <a:solidFill>
                   <a:srgbClr val="EE0000"/>
                 </a:solidFill>
-                <a:latin typeface="Overpass" pitchFamily="34" charset="0"/>
-                <a:ea typeface="Overpass" pitchFamily="34" charset="-122"/>
-                <a:cs typeface="Overpass" pitchFamily="34" charset="-120"/>
+                <a:latin typeface="Red Hat Display" pitchFamily="34" charset="0"/>
+                <a:ea typeface="Red Hat Display" pitchFamily="34" charset="-122"/>
+                <a:cs typeface="Red Hat Display" pitchFamily="34" charset="-120"/>
               </a:rPr>
               <a:t>COMMUNICATION · PROTOCOL FIT</a:t>
             </a:r>
@@ -3755,9 +3755,9 @@
                 <a:solidFill>
                   <a:srgbClr val="151515"/>
                 </a:solidFill>
-                <a:latin typeface="Overpass" pitchFamily="34" charset="0"/>
-                <a:ea typeface="Overpass" pitchFamily="34" charset="-122"/>
-                <a:cs typeface="Overpass" pitchFamily="34" charset="-120"/>
+                <a:latin typeface="Red Hat Display" pitchFamily="34" charset="0"/>
+                <a:ea typeface="Red Hat Display" pitchFamily="34" charset="-122"/>
+                <a:cs typeface="Red Hat Display" pitchFamily="34" charset="-120"/>
               </a:rPr>
               <a:t>REST, gRPC, and GraphQL each earn their seam</a:t>
             </a:r>
@@ -3944,9 +3944,9 @@
                 <a:solidFill>
                   <a:srgbClr val="EE0000"/>
                 </a:solidFill>
-                <a:latin typeface="Overpass" pitchFamily="34" charset="0"/>
-                <a:ea typeface="Overpass" pitchFamily="34" charset="-122"/>
-                <a:cs typeface="Overpass" pitchFamily="34" charset="-120"/>
+                <a:latin typeface="Red Hat Display" pitchFamily="34" charset="0"/>
+                <a:ea typeface="Red Hat Display" pitchFamily="34" charset="-122"/>
+                <a:cs typeface="Red Hat Display" pitchFamily="34" charset="-120"/>
               </a:rPr>
               <a:t>THE CUTOVER TIMELINE</a:t>
             </a:r>
@@ -3983,9 +3983,9 @@
                 <a:solidFill>
                   <a:srgbClr val="151515"/>
                 </a:solidFill>
-                <a:latin typeface="Overpass" pitchFamily="34" charset="0"/>
-                <a:ea typeface="Overpass" pitchFamily="34" charset="-122"/>
-                <a:cs typeface="Overpass" pitchFamily="34" charset="-120"/>
+                <a:latin typeface="Red Hat Display" pitchFamily="34" charset="0"/>
+                <a:ea typeface="Red Hat Display" pitchFamily="34" charset="-122"/>
+                <a:cs typeface="Red Hat Display" pitchFamily="34" charset="-120"/>
               </a:rPr>
               <a:t>Six seams, in dependency order</a:t>
             </a:r>
@@ -4140,9 +4140,9 @@
                 <a:solidFill>
                   <a:srgbClr val="FFFFFF"/>
                 </a:solidFill>
-                <a:latin typeface="Overpass" pitchFamily="34" charset="0"/>
-                <a:ea typeface="Overpass" pitchFamily="34" charset="-122"/>
-                <a:cs typeface="Overpass" pitchFamily="34" charset="-120"/>
+                <a:latin typeface="Red Hat Display" pitchFamily="34" charset="0"/>
+                <a:ea typeface="Red Hat Display" pitchFamily="34" charset="-122"/>
+                <a:cs typeface="Red Hat Display" pitchFamily="34" charset="-120"/>
               </a:rPr>
               <a:t>C</a:t>
             </a:r>
@@ -4179,9 +4179,9 @@
                 <a:solidFill>
                   <a:srgbClr val="FFFFFF"/>
                 </a:solidFill>
-                <a:latin typeface="Overpass" pitchFamily="34" charset="0"/>
-                <a:ea typeface="Overpass" pitchFamily="34" charset="-122"/>
-                <a:cs typeface="Overpass" pitchFamily="34" charset="-120"/>
+                <a:latin typeface="Red Hat Display" pitchFamily="34" charset="0"/>
+                <a:ea typeface="Red Hat Display" pitchFamily="34" charset="-122"/>
+                <a:cs typeface="Red Hat Display" pitchFamily="34" charset="-120"/>
               </a:rPr>
               <a:t>Operating &amp; Reflection</a:t>
             </a:r>
@@ -4369,9 +4369,9 @@
                 <a:solidFill>
                   <a:srgbClr val="EE0000"/>
                 </a:solidFill>
-                <a:latin typeface="Overpass" pitchFamily="34" charset="0"/>
-                <a:ea typeface="Overpass" pitchFamily="34" charset="-122"/>
-                <a:cs typeface="Overpass" pitchFamily="34" charset="-120"/>
+                <a:latin typeface="Red Hat Display" pitchFamily="34" charset="0"/>
+                <a:ea typeface="Red Hat Display" pitchFamily="34" charset="-122"/>
+                <a:cs typeface="Red Hat Display" pitchFamily="34" charset="-120"/>
               </a:rPr>
               <a:t>THE CHASSIS AS CONVENTION</a:t>
             </a:r>
@@ -4408,9 +4408,9 @@
                 <a:solidFill>
                   <a:srgbClr val="151515"/>
                 </a:solidFill>
-                <a:latin typeface="Overpass" pitchFamily="34" charset="0"/>
-                <a:ea typeface="Overpass" pitchFamily="34" charset="-122"/>
-                <a:cs typeface="Overpass" pitchFamily="34" charset="-120"/>
+                <a:latin typeface="Red Hat Display" pitchFamily="34" charset="0"/>
+                <a:ea typeface="Red Hat Display" pitchFamily="34" charset="-122"/>
+                <a:cs typeface="Red Hat Display" pitchFamily="34" charset="-120"/>
               </a:rPr>
               <a:t>The chassis is a convention, not a framework</a:t>
             </a:r>
@@ -4629,9 +4629,9 @@
                 <a:solidFill>
                   <a:srgbClr val="EE0000"/>
                 </a:solidFill>
-                <a:latin typeface="Overpass" pitchFamily="34" charset="0"/>
-                <a:ea typeface="Overpass" pitchFamily="34" charset="-122"/>
-                <a:cs typeface="Overpass" pitchFamily="34" charset="-120"/>
+                <a:latin typeface="Red Hat Display" pitchFamily="34" charset="0"/>
+                <a:ea typeface="Red Hat Display" pitchFamily="34" charset="-122"/>
+                <a:cs typeface="Red Hat Display" pitchFamily="34" charset="-120"/>
               </a:rPr>
               <a:t>OPERATING · THE MESH</a:t>
             </a:r>
@@ -4668,9 +4668,9 @@
                 <a:solidFill>
                   <a:srgbClr val="151515"/>
                 </a:solidFill>
-                <a:latin typeface="Overpass" pitchFamily="34" charset="0"/>
-                <a:ea typeface="Overpass" pitchFamily="34" charset="-122"/>
-                <a:cs typeface="Overpass" pitchFamily="34" charset="-120"/>
+                <a:latin typeface="Red Hat Display" pitchFamily="34" charset="0"/>
+                <a:ea typeface="Red Hat Display" pitchFamily="34" charset="-122"/>
+                <a:cs typeface="Red Hat Display" pitchFamily="34" charset="-120"/>
               </a:rPr>
               <a:t>mTLS and traffic identity, once services own their data</a:t>
             </a:r>
@@ -4857,9 +4857,9 @@
                 <a:solidFill>
                   <a:srgbClr val="EE0000"/>
                 </a:solidFill>
-                <a:latin typeface="Overpass" pitchFamily="34" charset="0"/>
-                <a:ea typeface="Overpass" pitchFamily="34" charset="-122"/>
-                <a:cs typeface="Overpass" pitchFamily="34" charset="-120"/>
+                <a:latin typeface="Red Hat Display" pitchFamily="34" charset="0"/>
+                <a:ea typeface="Red Hat Display" pitchFamily="34" charset="-122"/>
+                <a:cs typeface="Red Hat Display" pitchFamily="34" charset="-120"/>
               </a:rPr>
               <a:t>OPERATING · THE TRACE</a:t>
             </a:r>
@@ -4896,9 +4896,9 @@
                 <a:solidFill>
                   <a:srgbClr val="151515"/>
                 </a:solidFill>
-                <a:latin typeface="Overpass" pitchFamily="34" charset="0"/>
-                <a:ea typeface="Overpass" pitchFamily="34" charset="-122"/>
-                <a:cs typeface="Overpass" pitchFamily="34" charset="-120"/>
+                <a:latin typeface="Red Hat Display" pitchFamily="34" charset="0"/>
+                <a:ea typeface="Red Hat Display" pitchFamily="34" charset="-122"/>
+                <a:cs typeface="Red Hat Display" pitchFamily="34" charset="-120"/>
               </a:rPr>
               <a:t>One request, traced end to end</a:t>
             </a:r>
@@ -5085,9 +5085,9 @@
                 <a:solidFill>
                   <a:srgbClr val="EE0000"/>
                 </a:solidFill>
-                <a:latin typeface="Overpass" pitchFamily="34" charset="0"/>
-                <a:ea typeface="Overpass" pitchFamily="34" charset="-122"/>
-                <a:cs typeface="Overpass" pitchFamily="34" charset="-120"/>
+                <a:latin typeface="Red Hat Display" pitchFamily="34" charset="0"/>
+                <a:ea typeface="Red Hat Display" pitchFamily="34" charset="-122"/>
+                <a:cs typeface="Red Hat Display" pitchFamily="34" charset="-120"/>
               </a:rPr>
               <a:t>THE MEASURABLE WIN</a:t>
             </a:r>
@@ -5124,9 +5124,9 @@
                 <a:solidFill>
                   <a:srgbClr val="151515"/>
                 </a:solidFill>
-                <a:latin typeface="Overpass" pitchFamily="34" charset="0"/>
-                <a:ea typeface="Overpass" pitchFamily="34" charset="-122"/>
-                <a:cs typeface="Overpass" pitchFamily="34" charset="-120"/>
+                <a:latin typeface="Red Hat Display" pitchFamily="34" charset="0"/>
+                <a:ea typeface="Red Hat Display" pitchFamily="34" charset="-122"/>
+                <a:cs typeface="Red Hat Display" pitchFamily="34" charset="-120"/>
               </a:rPr>
               <a:t>The modernization, made measurable</a:t>
             </a:r>
@@ -5313,9 +5313,9 @@
                 <a:solidFill>
                   <a:srgbClr val="EE0000"/>
                 </a:solidFill>
-                <a:latin typeface="Overpass" pitchFamily="34" charset="0"/>
-                <a:ea typeface="Overpass" pitchFamily="34" charset="-122"/>
-                <a:cs typeface="Overpass" pitchFamily="34" charset="-120"/>
+                <a:latin typeface="Red Hat Display" pitchFamily="34" charset="0"/>
+                <a:ea typeface="Red Hat Display" pitchFamily="34" charset="-122"/>
+                <a:cs typeface="Red Hat Display" pitchFamily="34" charset="-120"/>
               </a:rPr>
               <a:t>THE RESULT</a:t>
             </a:r>
@@ -5352,9 +5352,9 @@
                 <a:solidFill>
                   <a:srgbClr val="151515"/>
                 </a:solidFill>
-                <a:latin typeface="Overpass" pitchFamily="34" charset="0"/>
-                <a:ea typeface="Overpass" pitchFamily="34" charset="-122"/>
-                <a:cs typeface="Overpass" pitchFamily="34" charset="-120"/>
+                <a:latin typeface="Red Hat Display" pitchFamily="34" charset="0"/>
+                <a:ea typeface="Red Hat Display" pitchFamily="34" charset="-122"/>
+                <a:cs typeface="Red Hat Display" pitchFamily="34" charset="-120"/>
               </a:rPr>
               <a:t>One monolith, six independent services</a:t>
             </a:r>
@@ -5541,9 +5541,9 @@
                 <a:solidFill>
                   <a:srgbClr val="EE0000"/>
                 </a:solidFill>
-                <a:latin typeface="Overpass" pitchFamily="34" charset="0"/>
-                <a:ea typeface="Overpass" pitchFamily="34" charset="-122"/>
-                <a:cs typeface="Overpass" pitchFamily="34" charset="-120"/>
+                <a:latin typeface="Red Hat Display" pitchFamily="34" charset="0"/>
+                <a:ea typeface="Red Hat Display" pitchFamily="34" charset="-122"/>
+                <a:cs typeface="Red Hat Display" pitchFamily="34" charset="-120"/>
               </a:rPr>
               <a:t>101 · THE IDEAS</a:t>
             </a:r>
@@ -5580,9 +5580,9 @@
                 <a:solidFill>
                   <a:srgbClr val="151515"/>
                 </a:solidFill>
-                <a:latin typeface="Overpass" pitchFamily="34" charset="0"/>
-                <a:ea typeface="Overpass" pitchFamily="34" charset="-122"/>
-                <a:cs typeface="Overpass" pitchFamily="34" charset="-120"/>
+                <a:latin typeface="Red Hat Display" pitchFamily="34" charset="0"/>
+                <a:ea typeface="Red Hat Display" pitchFamily="34" charset="-122"/>
+                <a:cs typeface="Red Hat Display" pitchFamily="34" charset="-120"/>
               </a:rPr>
               <a:t>The whole argument, in one sitting</a:t>
             </a:r>
@@ -5943,9 +5943,9 @@
                 <a:solidFill>
                   <a:srgbClr val="EE0000"/>
                 </a:solidFill>
-                <a:latin typeface="Overpass" pitchFamily="34" charset="0"/>
-                <a:ea typeface="Overpass" pitchFamily="34" charset="-122"/>
-                <a:cs typeface="Overpass" pitchFamily="34" charset="-120"/>
+                <a:latin typeface="Red Hat Display" pitchFamily="34" charset="0"/>
+                <a:ea typeface="Red Hat Display" pitchFamily="34" charset="-122"/>
+                <a:cs typeface="Red Hat Display" pitchFamily="34" charset="-120"/>
               </a:rPr>
               <a:t>REFLECTION · THE PATTERN MAP</a:t>
             </a:r>
@@ -5982,9 +5982,9 @@
                 <a:solidFill>
                   <a:srgbClr val="151515"/>
                 </a:solidFill>
-                <a:latin typeface="Overpass" pitchFamily="34" charset="0"/>
-                <a:ea typeface="Overpass" pitchFamily="34" charset="-122"/>
-                <a:cs typeface="Overpass" pitchFamily="34" charset="-120"/>
+                <a:latin typeface="Red Hat Display" pitchFamily="34" charset="0"/>
+                <a:ea typeface="Red Hat Display" pitchFamily="34" charset="-122"/>
+                <a:cs typeface="Red Hat Display" pitchFamily="34" charset="-120"/>
               </a:rPr>
               <a:t>Where each pattern lives in the language</a:t>
             </a:r>
@@ -6171,9 +6171,9 @@
                 <a:solidFill>
                   <a:srgbClr val="EE0000"/>
                 </a:solidFill>
-                <a:latin typeface="Overpass" pitchFamily="34" charset="0"/>
-                <a:ea typeface="Overpass" pitchFamily="34" charset="-122"/>
-                <a:cs typeface="Overpass" pitchFamily="34" charset="-120"/>
+                <a:latin typeface="Red Hat Display" pitchFamily="34" charset="0"/>
+                <a:ea typeface="Red Hat Display" pitchFamily="34" charset="-122"/>
+                <a:cs typeface="Red Hat Display" pitchFamily="34" charset="-120"/>
               </a:rPr>
               <a:t>REFLECTION · THE SCORECARD</a:t>
             </a:r>
@@ -6210,9 +6210,9 @@
                 <a:solidFill>
                   <a:srgbClr val="151515"/>
                 </a:solidFill>
-                <a:latin typeface="Overpass" pitchFamily="34" charset="0"/>
-                <a:ea typeface="Overpass" pitchFamily="34" charset="-122"/>
-                <a:cs typeface="Overpass" pitchFamily="34" charset="-120"/>
+                <a:latin typeface="Red Hat Display" pitchFamily="34" charset="0"/>
+                <a:ea typeface="Red Hat Display" pitchFamily="34" charset="-122"/>
+                <a:cs typeface="Red Hat Display" pitchFamily="34" charset="-120"/>
               </a:rPr>
               <a:t>A pattern belongs when it cures a pain you have</a:t>
             </a:r>
@@ -6399,9 +6399,9 @@
                 <a:solidFill>
                   <a:srgbClr val="EE0000"/>
                 </a:solidFill>
-                <a:latin typeface="Overpass" pitchFamily="34" charset="0"/>
-                <a:ea typeface="Overpass" pitchFamily="34" charset="-122"/>
-                <a:cs typeface="Overpass" pitchFamily="34" charset="-120"/>
+                <a:latin typeface="Red Hat Display" pitchFamily="34" charset="0"/>
+                <a:ea typeface="Red Hat Display" pitchFamily="34" charset="-122"/>
+                <a:cs typeface="Red Hat Display" pitchFamily="34" charset="-120"/>
               </a:rPr>
               <a:t>REFLECTION · WHERE TO STOP</a:t>
             </a:r>
@@ -6438,9 +6438,9 @@
                 <a:solidFill>
                   <a:srgbClr val="151515"/>
                 </a:solidFill>
-                <a:latin typeface="Overpass" pitchFamily="34" charset="0"/>
-                <a:ea typeface="Overpass" pitchFamily="34" charset="-122"/>
-                <a:cs typeface="Overpass" pitchFamily="34" charset="-120"/>
+                <a:latin typeface="Red Hat Display" pitchFamily="34" charset="0"/>
+                <a:ea typeface="Red Hat Display" pitchFamily="34" charset="-122"/>
+                <a:cs typeface="Red Hat Display" pitchFamily="34" charset="-120"/>
               </a:rPr>
               <a:t>Over-decomposition is the seductive failure</a:t>
             </a:r>
@@ -6659,9 +6659,9 @@
                 <a:solidFill>
                   <a:srgbClr val="EE0000"/>
                 </a:solidFill>
-                <a:latin typeface="Overpass" pitchFamily="34" charset="0"/>
-                <a:ea typeface="Overpass" pitchFamily="34" charset="-122"/>
-                <a:cs typeface="Overpass" pitchFamily="34" charset="-120"/>
+                <a:latin typeface="Red Hat Display" pitchFamily="34" charset="0"/>
+                <a:ea typeface="Red Hat Display" pitchFamily="34" charset="-122"/>
+                <a:cs typeface="Red Hat Display" pitchFamily="34" charset="-120"/>
               </a:rPr>
               <a:t>101 · CLOSE</a:t>
             </a:r>
@@ -6698,9 +6698,9 @@
                 <a:solidFill>
                   <a:srgbClr val="151515"/>
                 </a:solidFill>
-                <a:latin typeface="Overpass" pitchFamily="34" charset="0"/>
-                <a:ea typeface="Overpass" pitchFamily="34" charset="-122"/>
-                <a:cs typeface="Overpass" pitchFamily="34" charset="-120"/>
+                <a:latin typeface="Red Hat Display" pitchFamily="34" charset="0"/>
+                <a:ea typeface="Red Hat Display" pitchFamily="34" charset="-122"/>
+                <a:cs typeface="Red Hat Display" pitchFamily="34" charset="-120"/>
               </a:rPr>
               <a:t>One monolith, six services, a method that verifies itself</a:t>
             </a:r>
@@ -6919,9 +6919,9 @@
                 <a:solidFill>
                   <a:srgbClr val="EE0000"/>
                 </a:solidFill>
-                <a:latin typeface="Overpass" pitchFamily="34" charset="0"/>
-                <a:ea typeface="Overpass" pitchFamily="34" charset="-122"/>
-                <a:cs typeface="Overpass" pitchFamily="34" charset="-120"/>
+                <a:latin typeface="Red Hat Display" pitchFamily="34" charset="0"/>
+                <a:ea typeface="Red Hat Display" pitchFamily="34" charset="-122"/>
+                <a:cs typeface="Red Hat Display" pitchFamily="34" charset="-120"/>
               </a:rPr>
               <a:t>SCAN TO EXPLORE</a:t>
             </a:r>
@@ -6958,9 +6958,9 @@
                 <a:solidFill>
                   <a:srgbClr val="151515"/>
                 </a:solidFill>
-                <a:latin typeface="Overpass" pitchFamily="34" charset="0"/>
-                <a:ea typeface="Overpass" pitchFamily="34" charset="-122"/>
-                <a:cs typeface="Overpass" pitchFamily="34" charset="-120"/>
+                <a:latin typeface="Red Hat Display" pitchFamily="34" charset="0"/>
+                <a:ea typeface="Red Hat Display" pitchFamily="34" charset="-122"/>
+                <a:cs typeface="Red Hat Display" pitchFamily="34" charset="-120"/>
               </a:rPr>
               <a:t>Take it with you</a:t>
             </a:r>
@@ -7021,9 +7021,9 @@
                 <a:solidFill>
                   <a:srgbClr val="151515"/>
                 </a:solidFill>
-                <a:latin typeface="Overpass" pitchFamily="34" charset="0"/>
-                <a:ea typeface="Overpass" pitchFamily="34" charset="-122"/>
-                <a:cs typeface="Overpass" pitchFamily="34" charset="-120"/>
+                <a:latin typeface="Red Hat Display" pitchFamily="34" charset="0"/>
+                <a:ea typeface="Red Hat Display" pitchFamily="34" charset="-122"/>
+                <a:cs typeface="Red Hat Display" pitchFamily="34" charset="-120"/>
               </a:rPr>
               <a:t>The reference implementation</a:t>
             </a:r>
@@ -7162,9 +7162,9 @@
                 <a:solidFill>
                   <a:srgbClr val="151515"/>
                 </a:solidFill>
-                <a:latin typeface="Overpass" pitchFamily="34" charset="0"/>
-                <a:ea typeface="Overpass" pitchFamily="34" charset="-122"/>
-                <a:cs typeface="Overpass" pitchFamily="34" charset="-120"/>
+                <a:latin typeface="Red Hat Display" pitchFamily="34" charset="0"/>
+                <a:ea typeface="Red Hat Display" pitchFamily="34" charset="-122"/>
+                <a:cs typeface="Red Hat Display" pitchFamily="34" charset="-120"/>
               </a:rPr>
               <a:t>Workshops &amp; Tutorials</a:t>
             </a:r>
@@ -7335,9 +7335,9 @@
                 <a:solidFill>
                   <a:srgbClr val="FFFFFF"/>
                 </a:solidFill>
-                <a:latin typeface="Overpass" pitchFamily="34" charset="0"/>
-                <a:ea typeface="Overpass" pitchFamily="34" charset="-122"/>
-                <a:cs typeface="Overpass" pitchFamily="34" charset="-120"/>
+                <a:latin typeface="Red Hat Display" pitchFamily="34" charset="0"/>
+                <a:ea typeface="Red Hat Display" pitchFamily="34" charset="-122"/>
+                <a:cs typeface="Red Hat Display" pitchFamily="34" charset="-120"/>
               </a:rPr>
               <a:t>A</a:t>
             </a:r>
@@ -7374,9 +7374,9 @@
                 <a:solidFill>
                   <a:srgbClr val="FFFFFF"/>
                 </a:solidFill>
-                <a:latin typeface="Overpass" pitchFamily="34" charset="0"/>
-                <a:ea typeface="Overpass" pitchFamily="34" charset="-122"/>
-                <a:cs typeface="Overpass" pitchFamily="34" charset="-120"/>
+                <a:latin typeface="Red Hat Display" pitchFamily="34" charset="0"/>
+                <a:ea typeface="Red Hat Display" pitchFamily="34" charset="-122"/>
+                <a:cs typeface="Red Hat Display" pitchFamily="34" charset="-120"/>
               </a:rPr>
               <a:t>Why, and How</a:t>
             </a:r>
@@ -7564,9 +7564,9 @@
                 <a:solidFill>
                   <a:srgbClr val="EE0000"/>
                 </a:solidFill>
-                <a:latin typeface="Overpass" pitchFamily="34" charset="0"/>
-                <a:ea typeface="Overpass" pitchFamily="34" charset="-122"/>
-                <a:cs typeface="Overpass" pitchFamily="34" charset="-120"/>
+                <a:latin typeface="Red Hat Display" pitchFamily="34" charset="0"/>
+                <a:ea typeface="Red Hat Display" pitchFamily="34" charset="-122"/>
+                <a:cs typeface="Red Hat Display" pitchFamily="34" charset="-120"/>
               </a:rPr>
               <a:t>WHY MODERNIZE · THE CASE</a:t>
             </a:r>
@@ -7603,9 +7603,9 @@
                 <a:solidFill>
                   <a:srgbClr val="151515"/>
                 </a:solidFill>
-                <a:latin typeface="Overpass" pitchFamily="34" charset="0"/>
-                <a:ea typeface="Overpass" pitchFamily="34" charset="-122"/>
-                <a:cs typeface="Overpass" pitchFamily="34" charset="-120"/>
+                <a:latin typeface="Red Hat Display" pitchFamily="34" charset="0"/>
+                <a:ea typeface="Red Hat Display" pitchFamily="34" charset="-122"/>
+                <a:cs typeface="Red Hat Display" pitchFamily="34" charset="-120"/>
               </a:rPr>
               <a:t>Modernize because change got expensive</a:t>
             </a:r>
@@ -7824,9 +7824,9 @@
                 <a:solidFill>
                   <a:srgbClr val="EE0000"/>
                 </a:solidFill>
-                <a:latin typeface="Overpass" pitchFamily="34" charset="0"/>
-                <a:ea typeface="Overpass" pitchFamily="34" charset="-122"/>
-                <a:cs typeface="Overpass" pitchFamily="34" charset="-120"/>
+                <a:latin typeface="Red Hat Display" pitchFamily="34" charset="0"/>
+                <a:ea typeface="Red Hat Display" pitchFamily="34" charset="-122"/>
+                <a:cs typeface="Red Hat Display" pitchFamily="34" charset="-120"/>
               </a:rPr>
               <a:t>WHY MODERNIZE · RESTRAINT</a:t>
             </a:r>
@@ -7863,9 +7863,9 @@
                 <a:solidFill>
                   <a:srgbClr val="151515"/>
                 </a:solidFill>
-                <a:latin typeface="Overpass" pitchFamily="34" charset="0"/>
-                <a:ea typeface="Overpass" pitchFamily="34" charset="-122"/>
-                <a:cs typeface="Overpass" pitchFamily="34" charset="-120"/>
+                <a:latin typeface="Red Hat Display" pitchFamily="34" charset="0"/>
+                <a:ea typeface="Red Hat Display" pitchFamily="34" charset="-122"/>
+                <a:cs typeface="Red Hat Display" pitchFamily="34" charset="-120"/>
               </a:rPr>
               <a:t>And when not to modernize at all</a:t>
             </a:r>
@@ -8084,9 +8084,9 @@
                 <a:solidFill>
                   <a:srgbClr val="EE0000"/>
                 </a:solidFill>
-                <a:latin typeface="Overpass" pitchFamily="34" charset="0"/>
-                <a:ea typeface="Overpass" pitchFamily="34" charset="-122"/>
-                <a:cs typeface="Overpass" pitchFamily="34" charset="-120"/>
+                <a:latin typeface="Red Hat Display" pitchFamily="34" charset="0"/>
+                <a:ea typeface="Red Hat Display" pitchFamily="34" charset="-122"/>
+                <a:cs typeface="Red Hat Display" pitchFamily="34" charset="-120"/>
               </a:rPr>
               <a:t>THE STRANGLER FIG · THE METHOD</a:t>
             </a:r>
@@ -8123,9 +8123,9 @@
                 <a:solidFill>
                   <a:srgbClr val="151515"/>
                 </a:solidFill>
-                <a:latin typeface="Overpass" pitchFamily="34" charset="0"/>
-                <a:ea typeface="Overpass" pitchFamily="34" charset="-122"/>
-                <a:cs typeface="Overpass" pitchFamily="34" charset="-120"/>
+                <a:latin typeface="Red Hat Display" pitchFamily="34" charset="0"/>
+                <a:ea typeface="Red Hat Display" pitchFamily="34" charset="-122"/>
+                <a:cs typeface="Red Hat Display" pitchFamily="34" charset="-120"/>
               </a:rPr>
               <a:t>Grow the new system around the old</a:t>
             </a:r>
@@ -8280,9 +8280,9 @@
                 <a:solidFill>
                   <a:srgbClr val="FFFFFF"/>
                 </a:solidFill>
-                <a:latin typeface="Overpass" pitchFamily="34" charset="0"/>
-                <a:ea typeface="Overpass" pitchFamily="34" charset="-122"/>
-                <a:cs typeface="Overpass" pitchFamily="34" charset="-120"/>
+                <a:latin typeface="Red Hat Display" pitchFamily="34" charset="0"/>
+                <a:ea typeface="Red Hat Display" pitchFamily="34" charset="-122"/>
+                <a:cs typeface="Red Hat Display" pitchFamily="34" charset="-120"/>
               </a:rPr>
               <a:t>B</a:t>
             </a:r>
@@ -8319,9 +8319,9 @@
                 <a:solidFill>
                   <a:srgbClr val="FFFFFF"/>
                 </a:solidFill>
-                <a:latin typeface="Overpass" pitchFamily="34" charset="0"/>
-                <a:ea typeface="Overpass" pitchFamily="34" charset="-122"/>
-                <a:cs typeface="Overpass" pitchFamily="34" charset="-120"/>
+                <a:latin typeface="Red Hat Display" pitchFamily="34" charset="0"/>
+                <a:ea typeface="Red Hat Display" pitchFamily="34" charset="-122"/>
+                <a:cs typeface="Red Hat Display" pitchFamily="34" charset="-120"/>
               </a:rPr>
               <a:t>The Migration</a:t>
             </a:r>
@@ -8509,9 +8509,9 @@
                 <a:solidFill>
                   <a:srgbClr val="EE0000"/>
                 </a:solidFill>
-                <a:latin typeface="Overpass" pitchFamily="34" charset="0"/>
-                <a:ea typeface="Overpass" pitchFamily="34" charset="-122"/>
-                <a:cs typeface="Overpass" pitchFamily="34" charset="-120"/>
+                <a:latin typeface="Red Hat Display" pitchFamily="34" charset="0"/>
+                <a:ea typeface="Red Hat Display" pitchFamily="34" charset="-122"/>
+                <a:cs typeface="Red Hat Display" pitchFamily="34" charset="-120"/>
               </a:rPr>
               <a:t>THE STRANGLER FIG · PROXY ROUTING</a:t>
             </a:r>
@@ -8548,9 +8548,9 @@
                 <a:solidFill>
                   <a:srgbClr val="151515"/>
                 </a:solidFill>
-                <a:latin typeface="Overpass" pitchFamily="34" charset="0"/>
-                <a:ea typeface="Overpass" pitchFamily="34" charset="-122"/>
-                <a:cs typeface="Overpass" pitchFamily="34" charset="-120"/>
+                <a:latin typeface="Red Hat Display" pitchFamily="34" charset="0"/>
+                <a:ea typeface="Red Hat Display" pitchFamily="34" charset="-122"/>
+                <a:cs typeface="Red Hat Display" pitchFamily="34" charset="-120"/>
               </a:rPr>
               <a:t>A proxy in front, one seam out at a time</a:t>
             </a:r>
@@ -8737,9 +8737,9 @@
                 <a:solidFill>
                   <a:srgbClr val="EE0000"/>
                 </a:solidFill>
-                <a:latin typeface="Overpass" pitchFamily="34" charset="0"/>
-                <a:ea typeface="Overpass" pitchFamily="34" charset="-122"/>
-                <a:cs typeface="Overpass" pitchFamily="34" charset="-120"/>
+                <a:latin typeface="Red Hat Display" pitchFamily="34" charset="0"/>
+                <a:ea typeface="Red Hat Display" pitchFamily="34" charset="-122"/>
+                <a:cs typeface="Red Hat Display" pitchFamily="34" charset="-120"/>
               </a:rPr>
               <a:t>FINDING THE SEAMS</a:t>
             </a:r>
@@ -8776,9 +8776,9 @@
                 <a:solidFill>
                   <a:srgbClr val="151515"/>
                 </a:solidFill>
-                <a:latin typeface="Overpass" pitchFamily="34" charset="0"/>
-                <a:ea typeface="Overpass" pitchFamily="34" charset="-122"/>
-                <a:cs typeface="Overpass" pitchFamily="34" charset="-120"/>
+                <a:latin typeface="Red Hat Display" pitchFamily="34" charset="0"/>
+                <a:ea typeface="Red Hat Display" pitchFamily="34" charset="-122"/>
+                <a:cs typeface="Red Hat Display" pitchFamily="34" charset="-120"/>
               </a:rPr>
               <a:t>Seams are discovered, not invented</a:t>
             </a:r>

</xml_diff>

<commit_message>
docs(deck): voice + Red Hat Display pass on the modernizing decks (#26)
* docs(deck): professional-voice pass on the modernizing decks

Remove em dashes and internal chapter/section cross-references from
deck.js prose and speaker notes across modernizing-101,
modernizing-201, and modernizing-201-fastapi, then rebuild each pptx.

* docs(deck): Red Hat Display titles on the modernizing decks

Switch FONT.title from Overpass to Red Hat Display across
modernizing-101, modernizing-201, and modernizing-201-fastapi to
match the current house font standard.
</commit_message>
<xml_diff>
--- a/presentation/modernizing-101/Modernizing_101-r1.1.pptx
+++ b/presentation/modernizing-101/Modernizing_101-r1.1.pptx
@@ -2975,9 +2975,9 @@
                 <a:solidFill>
                   <a:srgbClr val="EE0000"/>
                 </a:solidFill>
-                <a:latin typeface="Overpass" pitchFamily="34" charset="0"/>
-                <a:ea typeface="Overpass" pitchFamily="34" charset="-122"/>
-                <a:cs typeface="Overpass" pitchFamily="34" charset="-120"/>
+                <a:latin typeface="Red Hat Display" pitchFamily="34" charset="0"/>
+                <a:ea typeface="Red Hat Display" pitchFamily="34" charset="-122"/>
+                <a:cs typeface="Red Hat Display" pitchFamily="34" charset="-120"/>
               </a:rPr>
               <a:t>MODERNIZING ENTERPRISE APPLICATIONS (PYTHON) · 101</a:t>
             </a:r>
@@ -3014,9 +3014,9 @@
                 <a:solidFill>
                   <a:srgbClr val="151515"/>
                 </a:solidFill>
-                <a:latin typeface="Overpass" pitchFamily="34" charset="0"/>
-                <a:ea typeface="Overpass" pitchFamily="34" charset="-122"/>
-                <a:cs typeface="Overpass" pitchFamily="34" charset="-120"/>
+                <a:latin typeface="Red Hat Display" pitchFamily="34" charset="0"/>
+                <a:ea typeface="Red Hat Display" pitchFamily="34" charset="-122"/>
+                <a:cs typeface="Red Hat Display" pitchFamily="34" charset="-120"/>
               </a:rPr>
               <a:t>Django to FastAPI,</a:t>
             </a:r>
@@ -3031,9 +3031,9 @@
                 <a:solidFill>
                   <a:srgbClr val="151515"/>
                 </a:solidFill>
-                <a:latin typeface="Overpass" pitchFamily="34" charset="0"/>
-                <a:ea typeface="Overpass" pitchFamily="34" charset="-122"/>
-                <a:cs typeface="Overpass" pitchFamily="34" charset="-120"/>
+                <a:latin typeface="Red Hat Display" pitchFamily="34" charset="0"/>
+                <a:ea typeface="Red Hat Display" pitchFamily="34" charset="-122"/>
+                <a:cs typeface="Red Hat Display" pitchFamily="34" charset="-120"/>
               </a:rPr>
               <a:t>one seam at a time</a:t>
             </a:r>
@@ -3260,9 +3260,9 @@
                 <a:solidFill>
                   <a:srgbClr val="EE0000"/>
                 </a:solidFill>
-                <a:latin typeface="Overpass" pitchFamily="34" charset="0"/>
-                <a:ea typeface="Overpass" pitchFamily="34" charset="-122"/>
-                <a:cs typeface="Overpass" pitchFamily="34" charset="-120"/>
+                <a:latin typeface="Red Hat Display" pitchFamily="34" charset="0"/>
+                <a:ea typeface="Red Hat Display" pitchFamily="34" charset="-122"/>
+                <a:cs typeface="Red Hat Display" pitchFamily="34" charset="-120"/>
               </a:rPr>
               <a:t>DATA ACROSS THE SEAM</a:t>
             </a:r>
@@ -3299,9 +3299,9 @@
                 <a:solidFill>
                   <a:srgbClr val="151515"/>
                 </a:solidFill>
-                <a:latin typeface="Overpass" pitchFamily="34" charset="0"/>
-                <a:ea typeface="Overpass" pitchFamily="34" charset="-122"/>
-                <a:cs typeface="Overpass" pitchFamily="34" charset="-120"/>
+                <a:latin typeface="Red Hat Display" pitchFamily="34" charset="0"/>
+                <a:ea typeface="Red Hat Display" pitchFamily="34" charset="-122"/>
+                <a:cs typeface="Red Hat Display" pitchFamily="34" charset="-120"/>
               </a:rPr>
               <a:t>Lead with owned data, not the shared schema</a:t>
             </a:r>
@@ -3488,9 +3488,9 @@
                 <a:solidFill>
                   <a:srgbClr val="EE0000"/>
                 </a:solidFill>
-                <a:latin typeface="Overpass" pitchFamily="34" charset="0"/>
-                <a:ea typeface="Overpass" pitchFamily="34" charset="-122"/>
-                <a:cs typeface="Overpass" pitchFamily="34" charset="-120"/>
+                <a:latin typeface="Red Hat Display" pitchFamily="34" charset="0"/>
+                <a:ea typeface="Red Hat Display" pitchFamily="34" charset="-122"/>
+                <a:cs typeface="Red Hat Display" pitchFamily="34" charset="-120"/>
               </a:rPr>
               <a:t>COORDINATING</a:t>
             </a:r>
@@ -3527,9 +3527,9 @@
                 <a:solidFill>
                   <a:srgbClr val="151515"/>
                 </a:solidFill>
-                <a:latin typeface="Overpass" pitchFamily="34" charset="0"/>
-                <a:ea typeface="Overpass" pitchFamily="34" charset="-122"/>
-                <a:cs typeface="Overpass" pitchFamily="34" charset="-120"/>
+                <a:latin typeface="Red Hat Display" pitchFamily="34" charset="0"/>
+                <a:ea typeface="Red Hat Display" pitchFamily="34" charset="-122"/>
+                <a:cs typeface="Red Hat Display" pitchFamily="34" charset="-120"/>
               </a:rPr>
               <a:t>Two ways to run a workflow across services</a:t>
             </a:r>
@@ -3716,9 +3716,9 @@
                 <a:solidFill>
                   <a:srgbClr val="EE0000"/>
                 </a:solidFill>
-                <a:latin typeface="Overpass" pitchFamily="34" charset="0"/>
-                <a:ea typeface="Overpass" pitchFamily="34" charset="-122"/>
-                <a:cs typeface="Overpass" pitchFamily="34" charset="-120"/>
+                <a:latin typeface="Red Hat Display" pitchFamily="34" charset="0"/>
+                <a:ea typeface="Red Hat Display" pitchFamily="34" charset="-122"/>
+                <a:cs typeface="Red Hat Display" pitchFamily="34" charset="-120"/>
               </a:rPr>
               <a:t>COMMUNICATION · PROTOCOL FIT</a:t>
             </a:r>
@@ -3755,9 +3755,9 @@
                 <a:solidFill>
                   <a:srgbClr val="151515"/>
                 </a:solidFill>
-                <a:latin typeface="Overpass" pitchFamily="34" charset="0"/>
-                <a:ea typeface="Overpass" pitchFamily="34" charset="-122"/>
-                <a:cs typeface="Overpass" pitchFamily="34" charset="-120"/>
+                <a:latin typeface="Red Hat Display" pitchFamily="34" charset="0"/>
+                <a:ea typeface="Red Hat Display" pitchFamily="34" charset="-122"/>
+                <a:cs typeface="Red Hat Display" pitchFamily="34" charset="-120"/>
               </a:rPr>
               <a:t>REST, gRPC, and GraphQL each earn their seam</a:t>
             </a:r>
@@ -3944,9 +3944,9 @@
                 <a:solidFill>
                   <a:srgbClr val="EE0000"/>
                 </a:solidFill>
-                <a:latin typeface="Overpass" pitchFamily="34" charset="0"/>
-                <a:ea typeface="Overpass" pitchFamily="34" charset="-122"/>
-                <a:cs typeface="Overpass" pitchFamily="34" charset="-120"/>
+                <a:latin typeface="Red Hat Display" pitchFamily="34" charset="0"/>
+                <a:ea typeface="Red Hat Display" pitchFamily="34" charset="-122"/>
+                <a:cs typeface="Red Hat Display" pitchFamily="34" charset="-120"/>
               </a:rPr>
               <a:t>THE CUTOVER TIMELINE</a:t>
             </a:r>
@@ -3983,9 +3983,9 @@
                 <a:solidFill>
                   <a:srgbClr val="151515"/>
                 </a:solidFill>
-                <a:latin typeface="Overpass" pitchFamily="34" charset="0"/>
-                <a:ea typeface="Overpass" pitchFamily="34" charset="-122"/>
-                <a:cs typeface="Overpass" pitchFamily="34" charset="-120"/>
+                <a:latin typeface="Red Hat Display" pitchFamily="34" charset="0"/>
+                <a:ea typeface="Red Hat Display" pitchFamily="34" charset="-122"/>
+                <a:cs typeface="Red Hat Display" pitchFamily="34" charset="-120"/>
               </a:rPr>
               <a:t>Six seams, in dependency order</a:t>
             </a:r>
@@ -4140,9 +4140,9 @@
                 <a:solidFill>
                   <a:srgbClr val="FFFFFF"/>
                 </a:solidFill>
-                <a:latin typeface="Overpass" pitchFamily="34" charset="0"/>
-                <a:ea typeface="Overpass" pitchFamily="34" charset="-122"/>
-                <a:cs typeface="Overpass" pitchFamily="34" charset="-120"/>
+                <a:latin typeface="Red Hat Display" pitchFamily="34" charset="0"/>
+                <a:ea typeface="Red Hat Display" pitchFamily="34" charset="-122"/>
+                <a:cs typeface="Red Hat Display" pitchFamily="34" charset="-120"/>
               </a:rPr>
               <a:t>C</a:t>
             </a:r>
@@ -4179,9 +4179,9 @@
                 <a:solidFill>
                   <a:srgbClr val="FFFFFF"/>
                 </a:solidFill>
-                <a:latin typeface="Overpass" pitchFamily="34" charset="0"/>
-                <a:ea typeface="Overpass" pitchFamily="34" charset="-122"/>
-                <a:cs typeface="Overpass" pitchFamily="34" charset="-120"/>
+                <a:latin typeface="Red Hat Display" pitchFamily="34" charset="0"/>
+                <a:ea typeface="Red Hat Display" pitchFamily="34" charset="-122"/>
+                <a:cs typeface="Red Hat Display" pitchFamily="34" charset="-120"/>
               </a:rPr>
               <a:t>Operating &amp; Reflection</a:t>
             </a:r>
@@ -4369,9 +4369,9 @@
                 <a:solidFill>
                   <a:srgbClr val="EE0000"/>
                 </a:solidFill>
-                <a:latin typeface="Overpass" pitchFamily="34" charset="0"/>
-                <a:ea typeface="Overpass" pitchFamily="34" charset="-122"/>
-                <a:cs typeface="Overpass" pitchFamily="34" charset="-120"/>
+                <a:latin typeface="Red Hat Display" pitchFamily="34" charset="0"/>
+                <a:ea typeface="Red Hat Display" pitchFamily="34" charset="-122"/>
+                <a:cs typeface="Red Hat Display" pitchFamily="34" charset="-120"/>
               </a:rPr>
               <a:t>THE CHASSIS AS CONVENTION</a:t>
             </a:r>
@@ -4408,9 +4408,9 @@
                 <a:solidFill>
                   <a:srgbClr val="151515"/>
                 </a:solidFill>
-                <a:latin typeface="Overpass" pitchFamily="34" charset="0"/>
-                <a:ea typeface="Overpass" pitchFamily="34" charset="-122"/>
-                <a:cs typeface="Overpass" pitchFamily="34" charset="-120"/>
+                <a:latin typeface="Red Hat Display" pitchFamily="34" charset="0"/>
+                <a:ea typeface="Red Hat Display" pitchFamily="34" charset="-122"/>
+                <a:cs typeface="Red Hat Display" pitchFamily="34" charset="-120"/>
               </a:rPr>
               <a:t>The chassis is a convention, not a framework</a:t>
             </a:r>
@@ -4629,9 +4629,9 @@
                 <a:solidFill>
                   <a:srgbClr val="EE0000"/>
                 </a:solidFill>
-                <a:latin typeface="Overpass" pitchFamily="34" charset="0"/>
-                <a:ea typeface="Overpass" pitchFamily="34" charset="-122"/>
-                <a:cs typeface="Overpass" pitchFamily="34" charset="-120"/>
+                <a:latin typeface="Red Hat Display" pitchFamily="34" charset="0"/>
+                <a:ea typeface="Red Hat Display" pitchFamily="34" charset="-122"/>
+                <a:cs typeface="Red Hat Display" pitchFamily="34" charset="-120"/>
               </a:rPr>
               <a:t>OPERATING · THE MESH</a:t>
             </a:r>
@@ -4668,9 +4668,9 @@
                 <a:solidFill>
                   <a:srgbClr val="151515"/>
                 </a:solidFill>
-                <a:latin typeface="Overpass" pitchFamily="34" charset="0"/>
-                <a:ea typeface="Overpass" pitchFamily="34" charset="-122"/>
-                <a:cs typeface="Overpass" pitchFamily="34" charset="-120"/>
+                <a:latin typeface="Red Hat Display" pitchFamily="34" charset="0"/>
+                <a:ea typeface="Red Hat Display" pitchFamily="34" charset="-122"/>
+                <a:cs typeface="Red Hat Display" pitchFamily="34" charset="-120"/>
               </a:rPr>
               <a:t>mTLS and traffic identity, once services own their data</a:t>
             </a:r>
@@ -4857,9 +4857,9 @@
                 <a:solidFill>
                   <a:srgbClr val="EE0000"/>
                 </a:solidFill>
-                <a:latin typeface="Overpass" pitchFamily="34" charset="0"/>
-                <a:ea typeface="Overpass" pitchFamily="34" charset="-122"/>
-                <a:cs typeface="Overpass" pitchFamily="34" charset="-120"/>
+                <a:latin typeface="Red Hat Display" pitchFamily="34" charset="0"/>
+                <a:ea typeface="Red Hat Display" pitchFamily="34" charset="-122"/>
+                <a:cs typeface="Red Hat Display" pitchFamily="34" charset="-120"/>
               </a:rPr>
               <a:t>OPERATING · THE TRACE</a:t>
             </a:r>
@@ -4896,9 +4896,9 @@
                 <a:solidFill>
                   <a:srgbClr val="151515"/>
                 </a:solidFill>
-                <a:latin typeface="Overpass" pitchFamily="34" charset="0"/>
-                <a:ea typeface="Overpass" pitchFamily="34" charset="-122"/>
-                <a:cs typeface="Overpass" pitchFamily="34" charset="-120"/>
+                <a:latin typeface="Red Hat Display" pitchFamily="34" charset="0"/>
+                <a:ea typeface="Red Hat Display" pitchFamily="34" charset="-122"/>
+                <a:cs typeface="Red Hat Display" pitchFamily="34" charset="-120"/>
               </a:rPr>
               <a:t>One request, traced end to end</a:t>
             </a:r>
@@ -5085,9 +5085,9 @@
                 <a:solidFill>
                   <a:srgbClr val="EE0000"/>
                 </a:solidFill>
-                <a:latin typeface="Overpass" pitchFamily="34" charset="0"/>
-                <a:ea typeface="Overpass" pitchFamily="34" charset="-122"/>
-                <a:cs typeface="Overpass" pitchFamily="34" charset="-120"/>
+                <a:latin typeface="Red Hat Display" pitchFamily="34" charset="0"/>
+                <a:ea typeface="Red Hat Display" pitchFamily="34" charset="-122"/>
+                <a:cs typeface="Red Hat Display" pitchFamily="34" charset="-120"/>
               </a:rPr>
               <a:t>THE MEASURABLE WIN</a:t>
             </a:r>
@@ -5124,9 +5124,9 @@
                 <a:solidFill>
                   <a:srgbClr val="151515"/>
                 </a:solidFill>
-                <a:latin typeface="Overpass" pitchFamily="34" charset="0"/>
-                <a:ea typeface="Overpass" pitchFamily="34" charset="-122"/>
-                <a:cs typeface="Overpass" pitchFamily="34" charset="-120"/>
+                <a:latin typeface="Red Hat Display" pitchFamily="34" charset="0"/>
+                <a:ea typeface="Red Hat Display" pitchFamily="34" charset="-122"/>
+                <a:cs typeface="Red Hat Display" pitchFamily="34" charset="-120"/>
               </a:rPr>
               <a:t>The modernization, made measurable</a:t>
             </a:r>
@@ -5313,9 +5313,9 @@
                 <a:solidFill>
                   <a:srgbClr val="EE0000"/>
                 </a:solidFill>
-                <a:latin typeface="Overpass" pitchFamily="34" charset="0"/>
-                <a:ea typeface="Overpass" pitchFamily="34" charset="-122"/>
-                <a:cs typeface="Overpass" pitchFamily="34" charset="-120"/>
+                <a:latin typeface="Red Hat Display" pitchFamily="34" charset="0"/>
+                <a:ea typeface="Red Hat Display" pitchFamily="34" charset="-122"/>
+                <a:cs typeface="Red Hat Display" pitchFamily="34" charset="-120"/>
               </a:rPr>
               <a:t>THE RESULT</a:t>
             </a:r>
@@ -5352,9 +5352,9 @@
                 <a:solidFill>
                   <a:srgbClr val="151515"/>
                 </a:solidFill>
-                <a:latin typeface="Overpass" pitchFamily="34" charset="0"/>
-                <a:ea typeface="Overpass" pitchFamily="34" charset="-122"/>
-                <a:cs typeface="Overpass" pitchFamily="34" charset="-120"/>
+                <a:latin typeface="Red Hat Display" pitchFamily="34" charset="0"/>
+                <a:ea typeface="Red Hat Display" pitchFamily="34" charset="-122"/>
+                <a:cs typeface="Red Hat Display" pitchFamily="34" charset="-120"/>
               </a:rPr>
               <a:t>One monolith, six independent services</a:t>
             </a:r>
@@ -5541,9 +5541,9 @@
                 <a:solidFill>
                   <a:srgbClr val="EE0000"/>
                 </a:solidFill>
-                <a:latin typeface="Overpass" pitchFamily="34" charset="0"/>
-                <a:ea typeface="Overpass" pitchFamily="34" charset="-122"/>
-                <a:cs typeface="Overpass" pitchFamily="34" charset="-120"/>
+                <a:latin typeface="Red Hat Display" pitchFamily="34" charset="0"/>
+                <a:ea typeface="Red Hat Display" pitchFamily="34" charset="-122"/>
+                <a:cs typeface="Red Hat Display" pitchFamily="34" charset="-120"/>
               </a:rPr>
               <a:t>101 · THE IDEAS</a:t>
             </a:r>
@@ -5580,9 +5580,9 @@
                 <a:solidFill>
                   <a:srgbClr val="151515"/>
                 </a:solidFill>
-                <a:latin typeface="Overpass" pitchFamily="34" charset="0"/>
-                <a:ea typeface="Overpass" pitchFamily="34" charset="-122"/>
-                <a:cs typeface="Overpass" pitchFamily="34" charset="-120"/>
+                <a:latin typeface="Red Hat Display" pitchFamily="34" charset="0"/>
+                <a:ea typeface="Red Hat Display" pitchFamily="34" charset="-122"/>
+                <a:cs typeface="Red Hat Display" pitchFamily="34" charset="-120"/>
               </a:rPr>
               <a:t>The whole argument, in one sitting</a:t>
             </a:r>
@@ -5943,9 +5943,9 @@
                 <a:solidFill>
                   <a:srgbClr val="EE0000"/>
                 </a:solidFill>
-                <a:latin typeface="Overpass" pitchFamily="34" charset="0"/>
-                <a:ea typeface="Overpass" pitchFamily="34" charset="-122"/>
-                <a:cs typeface="Overpass" pitchFamily="34" charset="-120"/>
+                <a:latin typeface="Red Hat Display" pitchFamily="34" charset="0"/>
+                <a:ea typeface="Red Hat Display" pitchFamily="34" charset="-122"/>
+                <a:cs typeface="Red Hat Display" pitchFamily="34" charset="-120"/>
               </a:rPr>
               <a:t>REFLECTION · THE PATTERN MAP</a:t>
             </a:r>
@@ -5982,9 +5982,9 @@
                 <a:solidFill>
                   <a:srgbClr val="151515"/>
                 </a:solidFill>
-                <a:latin typeface="Overpass" pitchFamily="34" charset="0"/>
-                <a:ea typeface="Overpass" pitchFamily="34" charset="-122"/>
-                <a:cs typeface="Overpass" pitchFamily="34" charset="-120"/>
+                <a:latin typeface="Red Hat Display" pitchFamily="34" charset="0"/>
+                <a:ea typeface="Red Hat Display" pitchFamily="34" charset="-122"/>
+                <a:cs typeface="Red Hat Display" pitchFamily="34" charset="-120"/>
               </a:rPr>
               <a:t>Where each pattern lives in the language</a:t>
             </a:r>
@@ -6171,9 +6171,9 @@
                 <a:solidFill>
                   <a:srgbClr val="EE0000"/>
                 </a:solidFill>
-                <a:latin typeface="Overpass" pitchFamily="34" charset="0"/>
-                <a:ea typeface="Overpass" pitchFamily="34" charset="-122"/>
-                <a:cs typeface="Overpass" pitchFamily="34" charset="-120"/>
+                <a:latin typeface="Red Hat Display" pitchFamily="34" charset="0"/>
+                <a:ea typeface="Red Hat Display" pitchFamily="34" charset="-122"/>
+                <a:cs typeface="Red Hat Display" pitchFamily="34" charset="-120"/>
               </a:rPr>
               <a:t>REFLECTION · THE SCORECARD</a:t>
             </a:r>
@@ -6210,9 +6210,9 @@
                 <a:solidFill>
                   <a:srgbClr val="151515"/>
                 </a:solidFill>
-                <a:latin typeface="Overpass" pitchFamily="34" charset="0"/>
-                <a:ea typeface="Overpass" pitchFamily="34" charset="-122"/>
-                <a:cs typeface="Overpass" pitchFamily="34" charset="-120"/>
+                <a:latin typeface="Red Hat Display" pitchFamily="34" charset="0"/>
+                <a:ea typeface="Red Hat Display" pitchFamily="34" charset="-122"/>
+                <a:cs typeface="Red Hat Display" pitchFamily="34" charset="-120"/>
               </a:rPr>
               <a:t>A pattern belongs when it cures a pain you have</a:t>
             </a:r>
@@ -6399,9 +6399,9 @@
                 <a:solidFill>
                   <a:srgbClr val="EE0000"/>
                 </a:solidFill>
-                <a:latin typeface="Overpass" pitchFamily="34" charset="0"/>
-                <a:ea typeface="Overpass" pitchFamily="34" charset="-122"/>
-                <a:cs typeface="Overpass" pitchFamily="34" charset="-120"/>
+                <a:latin typeface="Red Hat Display" pitchFamily="34" charset="0"/>
+                <a:ea typeface="Red Hat Display" pitchFamily="34" charset="-122"/>
+                <a:cs typeface="Red Hat Display" pitchFamily="34" charset="-120"/>
               </a:rPr>
               <a:t>REFLECTION · WHERE TO STOP</a:t>
             </a:r>
@@ -6438,9 +6438,9 @@
                 <a:solidFill>
                   <a:srgbClr val="151515"/>
                 </a:solidFill>
-                <a:latin typeface="Overpass" pitchFamily="34" charset="0"/>
-                <a:ea typeface="Overpass" pitchFamily="34" charset="-122"/>
-                <a:cs typeface="Overpass" pitchFamily="34" charset="-120"/>
+                <a:latin typeface="Red Hat Display" pitchFamily="34" charset="0"/>
+                <a:ea typeface="Red Hat Display" pitchFamily="34" charset="-122"/>
+                <a:cs typeface="Red Hat Display" pitchFamily="34" charset="-120"/>
               </a:rPr>
               <a:t>Over-decomposition is the seductive failure</a:t>
             </a:r>
@@ -6659,9 +6659,9 @@
                 <a:solidFill>
                   <a:srgbClr val="EE0000"/>
                 </a:solidFill>
-                <a:latin typeface="Overpass" pitchFamily="34" charset="0"/>
-                <a:ea typeface="Overpass" pitchFamily="34" charset="-122"/>
-                <a:cs typeface="Overpass" pitchFamily="34" charset="-120"/>
+                <a:latin typeface="Red Hat Display" pitchFamily="34" charset="0"/>
+                <a:ea typeface="Red Hat Display" pitchFamily="34" charset="-122"/>
+                <a:cs typeface="Red Hat Display" pitchFamily="34" charset="-120"/>
               </a:rPr>
               <a:t>101 · CLOSE</a:t>
             </a:r>
@@ -6698,9 +6698,9 @@
                 <a:solidFill>
                   <a:srgbClr val="151515"/>
                 </a:solidFill>
-                <a:latin typeface="Overpass" pitchFamily="34" charset="0"/>
-                <a:ea typeface="Overpass" pitchFamily="34" charset="-122"/>
-                <a:cs typeface="Overpass" pitchFamily="34" charset="-120"/>
+                <a:latin typeface="Red Hat Display" pitchFamily="34" charset="0"/>
+                <a:ea typeface="Red Hat Display" pitchFamily="34" charset="-122"/>
+                <a:cs typeface="Red Hat Display" pitchFamily="34" charset="-120"/>
               </a:rPr>
               <a:t>One monolith, six services, a method that verifies itself</a:t>
             </a:r>
@@ -6919,9 +6919,9 @@
                 <a:solidFill>
                   <a:srgbClr val="EE0000"/>
                 </a:solidFill>
-                <a:latin typeface="Overpass" pitchFamily="34" charset="0"/>
-                <a:ea typeface="Overpass" pitchFamily="34" charset="-122"/>
-                <a:cs typeface="Overpass" pitchFamily="34" charset="-120"/>
+                <a:latin typeface="Red Hat Display" pitchFamily="34" charset="0"/>
+                <a:ea typeface="Red Hat Display" pitchFamily="34" charset="-122"/>
+                <a:cs typeface="Red Hat Display" pitchFamily="34" charset="-120"/>
               </a:rPr>
               <a:t>SCAN TO EXPLORE</a:t>
             </a:r>
@@ -6958,9 +6958,9 @@
                 <a:solidFill>
                   <a:srgbClr val="151515"/>
                 </a:solidFill>
-                <a:latin typeface="Overpass" pitchFamily="34" charset="0"/>
-                <a:ea typeface="Overpass" pitchFamily="34" charset="-122"/>
-                <a:cs typeface="Overpass" pitchFamily="34" charset="-120"/>
+                <a:latin typeface="Red Hat Display" pitchFamily="34" charset="0"/>
+                <a:ea typeface="Red Hat Display" pitchFamily="34" charset="-122"/>
+                <a:cs typeface="Red Hat Display" pitchFamily="34" charset="-120"/>
               </a:rPr>
               <a:t>Take it with you</a:t>
             </a:r>
@@ -7021,9 +7021,9 @@
                 <a:solidFill>
                   <a:srgbClr val="151515"/>
                 </a:solidFill>
-                <a:latin typeface="Overpass" pitchFamily="34" charset="0"/>
-                <a:ea typeface="Overpass" pitchFamily="34" charset="-122"/>
-                <a:cs typeface="Overpass" pitchFamily="34" charset="-120"/>
+                <a:latin typeface="Red Hat Display" pitchFamily="34" charset="0"/>
+                <a:ea typeface="Red Hat Display" pitchFamily="34" charset="-122"/>
+                <a:cs typeface="Red Hat Display" pitchFamily="34" charset="-120"/>
               </a:rPr>
               <a:t>The reference implementation</a:t>
             </a:r>
@@ -7162,9 +7162,9 @@
                 <a:solidFill>
                   <a:srgbClr val="151515"/>
                 </a:solidFill>
-                <a:latin typeface="Overpass" pitchFamily="34" charset="0"/>
-                <a:ea typeface="Overpass" pitchFamily="34" charset="-122"/>
-                <a:cs typeface="Overpass" pitchFamily="34" charset="-120"/>
+                <a:latin typeface="Red Hat Display" pitchFamily="34" charset="0"/>
+                <a:ea typeface="Red Hat Display" pitchFamily="34" charset="-122"/>
+                <a:cs typeface="Red Hat Display" pitchFamily="34" charset="-120"/>
               </a:rPr>
               <a:t>Workshops &amp; Tutorials</a:t>
             </a:r>
@@ -7335,9 +7335,9 @@
                 <a:solidFill>
                   <a:srgbClr val="FFFFFF"/>
                 </a:solidFill>
-                <a:latin typeface="Overpass" pitchFamily="34" charset="0"/>
-                <a:ea typeface="Overpass" pitchFamily="34" charset="-122"/>
-                <a:cs typeface="Overpass" pitchFamily="34" charset="-120"/>
+                <a:latin typeface="Red Hat Display" pitchFamily="34" charset="0"/>
+                <a:ea typeface="Red Hat Display" pitchFamily="34" charset="-122"/>
+                <a:cs typeface="Red Hat Display" pitchFamily="34" charset="-120"/>
               </a:rPr>
               <a:t>A</a:t>
             </a:r>
@@ -7374,9 +7374,9 @@
                 <a:solidFill>
                   <a:srgbClr val="FFFFFF"/>
                 </a:solidFill>
-                <a:latin typeface="Overpass" pitchFamily="34" charset="0"/>
-                <a:ea typeface="Overpass" pitchFamily="34" charset="-122"/>
-                <a:cs typeface="Overpass" pitchFamily="34" charset="-120"/>
+                <a:latin typeface="Red Hat Display" pitchFamily="34" charset="0"/>
+                <a:ea typeface="Red Hat Display" pitchFamily="34" charset="-122"/>
+                <a:cs typeface="Red Hat Display" pitchFamily="34" charset="-120"/>
               </a:rPr>
               <a:t>Why, and How</a:t>
             </a:r>
@@ -7564,9 +7564,9 @@
                 <a:solidFill>
                   <a:srgbClr val="EE0000"/>
                 </a:solidFill>
-                <a:latin typeface="Overpass" pitchFamily="34" charset="0"/>
-                <a:ea typeface="Overpass" pitchFamily="34" charset="-122"/>
-                <a:cs typeface="Overpass" pitchFamily="34" charset="-120"/>
+                <a:latin typeface="Red Hat Display" pitchFamily="34" charset="0"/>
+                <a:ea typeface="Red Hat Display" pitchFamily="34" charset="-122"/>
+                <a:cs typeface="Red Hat Display" pitchFamily="34" charset="-120"/>
               </a:rPr>
               <a:t>WHY MODERNIZE · THE CASE</a:t>
             </a:r>
@@ -7603,9 +7603,9 @@
                 <a:solidFill>
                   <a:srgbClr val="151515"/>
                 </a:solidFill>
-                <a:latin typeface="Overpass" pitchFamily="34" charset="0"/>
-                <a:ea typeface="Overpass" pitchFamily="34" charset="-122"/>
-                <a:cs typeface="Overpass" pitchFamily="34" charset="-120"/>
+                <a:latin typeface="Red Hat Display" pitchFamily="34" charset="0"/>
+                <a:ea typeface="Red Hat Display" pitchFamily="34" charset="-122"/>
+                <a:cs typeface="Red Hat Display" pitchFamily="34" charset="-120"/>
               </a:rPr>
               <a:t>Modernize because change got expensive</a:t>
             </a:r>
@@ -7824,9 +7824,9 @@
                 <a:solidFill>
                   <a:srgbClr val="EE0000"/>
                 </a:solidFill>
-                <a:latin typeface="Overpass" pitchFamily="34" charset="0"/>
-                <a:ea typeface="Overpass" pitchFamily="34" charset="-122"/>
-                <a:cs typeface="Overpass" pitchFamily="34" charset="-120"/>
+                <a:latin typeface="Red Hat Display" pitchFamily="34" charset="0"/>
+                <a:ea typeface="Red Hat Display" pitchFamily="34" charset="-122"/>
+                <a:cs typeface="Red Hat Display" pitchFamily="34" charset="-120"/>
               </a:rPr>
               <a:t>WHY MODERNIZE · RESTRAINT</a:t>
             </a:r>
@@ -7863,9 +7863,9 @@
                 <a:solidFill>
                   <a:srgbClr val="151515"/>
                 </a:solidFill>
-                <a:latin typeface="Overpass" pitchFamily="34" charset="0"/>
-                <a:ea typeface="Overpass" pitchFamily="34" charset="-122"/>
-                <a:cs typeface="Overpass" pitchFamily="34" charset="-120"/>
+                <a:latin typeface="Red Hat Display" pitchFamily="34" charset="0"/>
+                <a:ea typeface="Red Hat Display" pitchFamily="34" charset="-122"/>
+                <a:cs typeface="Red Hat Display" pitchFamily="34" charset="-120"/>
               </a:rPr>
               <a:t>And when not to modernize at all</a:t>
             </a:r>
@@ -8084,9 +8084,9 @@
                 <a:solidFill>
                   <a:srgbClr val="EE0000"/>
                 </a:solidFill>
-                <a:latin typeface="Overpass" pitchFamily="34" charset="0"/>
-                <a:ea typeface="Overpass" pitchFamily="34" charset="-122"/>
-                <a:cs typeface="Overpass" pitchFamily="34" charset="-120"/>
+                <a:latin typeface="Red Hat Display" pitchFamily="34" charset="0"/>
+                <a:ea typeface="Red Hat Display" pitchFamily="34" charset="-122"/>
+                <a:cs typeface="Red Hat Display" pitchFamily="34" charset="-120"/>
               </a:rPr>
               <a:t>THE STRANGLER FIG · THE METHOD</a:t>
             </a:r>
@@ -8123,9 +8123,9 @@
                 <a:solidFill>
                   <a:srgbClr val="151515"/>
                 </a:solidFill>
-                <a:latin typeface="Overpass" pitchFamily="34" charset="0"/>
-                <a:ea typeface="Overpass" pitchFamily="34" charset="-122"/>
-                <a:cs typeface="Overpass" pitchFamily="34" charset="-120"/>
+                <a:latin typeface="Red Hat Display" pitchFamily="34" charset="0"/>
+                <a:ea typeface="Red Hat Display" pitchFamily="34" charset="-122"/>
+                <a:cs typeface="Red Hat Display" pitchFamily="34" charset="-120"/>
               </a:rPr>
               <a:t>Grow the new system around the old</a:t>
             </a:r>
@@ -8280,9 +8280,9 @@
                 <a:solidFill>
                   <a:srgbClr val="FFFFFF"/>
                 </a:solidFill>
-                <a:latin typeface="Overpass" pitchFamily="34" charset="0"/>
-                <a:ea typeface="Overpass" pitchFamily="34" charset="-122"/>
-                <a:cs typeface="Overpass" pitchFamily="34" charset="-120"/>
+                <a:latin typeface="Red Hat Display" pitchFamily="34" charset="0"/>
+                <a:ea typeface="Red Hat Display" pitchFamily="34" charset="-122"/>
+                <a:cs typeface="Red Hat Display" pitchFamily="34" charset="-120"/>
               </a:rPr>
               <a:t>B</a:t>
             </a:r>
@@ -8319,9 +8319,9 @@
                 <a:solidFill>
                   <a:srgbClr val="FFFFFF"/>
                 </a:solidFill>
-                <a:latin typeface="Overpass" pitchFamily="34" charset="0"/>
-                <a:ea typeface="Overpass" pitchFamily="34" charset="-122"/>
-                <a:cs typeface="Overpass" pitchFamily="34" charset="-120"/>
+                <a:latin typeface="Red Hat Display" pitchFamily="34" charset="0"/>
+                <a:ea typeface="Red Hat Display" pitchFamily="34" charset="-122"/>
+                <a:cs typeface="Red Hat Display" pitchFamily="34" charset="-120"/>
               </a:rPr>
               <a:t>The Migration</a:t>
             </a:r>
@@ -8509,9 +8509,9 @@
                 <a:solidFill>
                   <a:srgbClr val="EE0000"/>
                 </a:solidFill>
-                <a:latin typeface="Overpass" pitchFamily="34" charset="0"/>
-                <a:ea typeface="Overpass" pitchFamily="34" charset="-122"/>
-                <a:cs typeface="Overpass" pitchFamily="34" charset="-120"/>
+                <a:latin typeface="Red Hat Display" pitchFamily="34" charset="0"/>
+                <a:ea typeface="Red Hat Display" pitchFamily="34" charset="-122"/>
+                <a:cs typeface="Red Hat Display" pitchFamily="34" charset="-120"/>
               </a:rPr>
               <a:t>THE STRANGLER FIG · PROXY ROUTING</a:t>
             </a:r>
@@ -8548,9 +8548,9 @@
                 <a:solidFill>
                   <a:srgbClr val="151515"/>
                 </a:solidFill>
-                <a:latin typeface="Overpass" pitchFamily="34" charset="0"/>
-                <a:ea typeface="Overpass" pitchFamily="34" charset="-122"/>
-                <a:cs typeface="Overpass" pitchFamily="34" charset="-120"/>
+                <a:latin typeface="Red Hat Display" pitchFamily="34" charset="0"/>
+                <a:ea typeface="Red Hat Display" pitchFamily="34" charset="-122"/>
+                <a:cs typeface="Red Hat Display" pitchFamily="34" charset="-120"/>
               </a:rPr>
               <a:t>A proxy in front, one seam out at a time</a:t>
             </a:r>
@@ -8737,9 +8737,9 @@
                 <a:solidFill>
                   <a:srgbClr val="EE0000"/>
                 </a:solidFill>
-                <a:latin typeface="Overpass" pitchFamily="34" charset="0"/>
-                <a:ea typeface="Overpass" pitchFamily="34" charset="-122"/>
-                <a:cs typeface="Overpass" pitchFamily="34" charset="-120"/>
+                <a:latin typeface="Red Hat Display" pitchFamily="34" charset="0"/>
+                <a:ea typeface="Red Hat Display" pitchFamily="34" charset="-122"/>
+                <a:cs typeface="Red Hat Display" pitchFamily="34" charset="-120"/>
               </a:rPr>
               <a:t>FINDING THE SEAMS</a:t>
             </a:r>
@@ -8776,9 +8776,9 @@
                 <a:solidFill>
                   <a:srgbClr val="151515"/>
                 </a:solidFill>
-                <a:latin typeface="Overpass" pitchFamily="34" charset="0"/>
-                <a:ea typeface="Overpass" pitchFamily="34" charset="-122"/>
-                <a:cs typeface="Overpass" pitchFamily="34" charset="-120"/>
+                <a:latin typeface="Red Hat Display" pitchFamily="34" charset="0"/>
+                <a:ea typeface="Red Hat Display" pitchFamily="34" charset="-122"/>
+                <a:cs typeface="Red Hat Display" pitchFamily="34" charset="-120"/>
               </a:rPr>
               <a:t>Seams are discovered, not invented</a:t>
             </a:r>

</xml_diff>